<commit_message>
added to presentation, updated weekly log
</commit_message>
<xml_diff>
--- a/Academic Documents/Powerpoint wkg/Mid project Update - Sam v1 10-09.pptx
+++ b/Academic Documents/Powerpoint wkg/Mid project Update - Sam v1 10-09.pptx
@@ -11,8 +11,8 @@
     <p:sldId id="259" r:id="rId5"/>
     <p:sldId id="264" r:id="rId6"/>
     <p:sldId id="263" r:id="rId7"/>
-    <p:sldId id="268" r:id="rId8"/>
-    <p:sldId id="267" r:id="rId9"/>
+    <p:sldId id="267" r:id="rId8"/>
+    <p:sldId id="268" r:id="rId9"/>
     <p:sldId id="262" r:id="rId10"/>
     <p:sldId id="261" r:id="rId11"/>
     <p:sldId id="260" r:id="rId12"/>
@@ -308,7 +308,7 @@
           <a:p>
             <a:fld id="{82AFC869-5EEF-42A8-8244-0DD91ADCD842}" type="datetimeFigureOut">
               <a:rPr lang="en-NZ" smtClean="0"/>
-              <a:t>10/09/2026</a:t>
+              <a:t>12/09/2026</a:t>
             </a:fld>
             <a:endParaRPr lang="en-NZ"/>
           </a:p>
@@ -583,7 +583,7 @@
           <a:p>
             <a:fld id="{82AFC869-5EEF-42A8-8244-0DD91ADCD842}" type="datetimeFigureOut">
               <a:rPr lang="en-NZ" smtClean="0"/>
-              <a:t>10/09/2026</a:t>
+              <a:t>12/09/2026</a:t>
             </a:fld>
             <a:endParaRPr lang="en-NZ"/>
           </a:p>
@@ -777,7 +777,7 @@
           <a:p>
             <a:fld id="{82AFC869-5EEF-42A8-8244-0DD91ADCD842}" type="datetimeFigureOut">
               <a:rPr lang="en-NZ" smtClean="0"/>
-              <a:t>10/09/2026</a:t>
+              <a:t>12/09/2026</a:t>
             </a:fld>
             <a:endParaRPr lang="en-NZ"/>
           </a:p>
@@ -1050,7 +1050,7 @@
           <a:p>
             <a:fld id="{82AFC869-5EEF-42A8-8244-0DD91ADCD842}" type="datetimeFigureOut">
               <a:rPr lang="en-NZ" smtClean="0"/>
-              <a:t>10/09/2026</a:t>
+              <a:t>12/09/2026</a:t>
             </a:fld>
             <a:endParaRPr lang="en-NZ"/>
           </a:p>
@@ -1391,7 +1391,7 @@
           <a:p>
             <a:fld id="{82AFC869-5EEF-42A8-8244-0DD91ADCD842}" type="datetimeFigureOut">
               <a:rPr lang="en-NZ" smtClean="0"/>
-              <a:t>10/09/2026</a:t>
+              <a:t>12/09/2026</a:t>
             </a:fld>
             <a:endParaRPr lang="en-NZ"/>
           </a:p>
@@ -2014,7 +2014,7 @@
           <a:p>
             <a:fld id="{82AFC869-5EEF-42A8-8244-0DD91ADCD842}" type="datetimeFigureOut">
               <a:rPr lang="en-NZ" smtClean="0"/>
-              <a:t>10/09/2026</a:t>
+              <a:t>12/09/2026</a:t>
             </a:fld>
             <a:endParaRPr lang="en-NZ"/>
           </a:p>
@@ -2874,7 +2874,7 @@
           <a:p>
             <a:fld id="{82AFC869-5EEF-42A8-8244-0DD91ADCD842}" type="datetimeFigureOut">
               <a:rPr lang="en-NZ" smtClean="0"/>
-              <a:t>10/09/2026</a:t>
+              <a:t>12/09/2026</a:t>
             </a:fld>
             <a:endParaRPr lang="en-NZ"/>
           </a:p>
@@ -3044,7 +3044,7 @@
           <a:p>
             <a:fld id="{82AFC869-5EEF-42A8-8244-0DD91ADCD842}" type="datetimeFigureOut">
               <a:rPr lang="en-NZ" smtClean="0"/>
-              <a:t>10/09/2026</a:t>
+              <a:t>12/09/2026</a:t>
             </a:fld>
             <a:endParaRPr lang="en-NZ"/>
           </a:p>
@@ -3224,7 +3224,7 @@
           <a:p>
             <a:fld id="{82AFC869-5EEF-42A8-8244-0DD91ADCD842}" type="datetimeFigureOut">
               <a:rPr lang="en-NZ" smtClean="0"/>
-              <a:t>10/09/2026</a:t>
+              <a:t>12/09/2026</a:t>
             </a:fld>
             <a:endParaRPr lang="en-NZ"/>
           </a:p>
@@ -3394,7 +3394,7 @@
           <a:p>
             <a:fld id="{82AFC869-5EEF-42A8-8244-0DD91ADCD842}" type="datetimeFigureOut">
               <a:rPr lang="en-NZ" smtClean="0"/>
-              <a:t>10/09/2026</a:t>
+              <a:t>12/09/2026</a:t>
             </a:fld>
             <a:endParaRPr lang="en-NZ"/>
           </a:p>
@@ -3641,7 +3641,7 @@
           <a:p>
             <a:fld id="{82AFC869-5EEF-42A8-8244-0DD91ADCD842}" type="datetimeFigureOut">
               <a:rPr lang="en-NZ" smtClean="0"/>
-              <a:t>10/09/2026</a:t>
+              <a:t>12/09/2026</a:t>
             </a:fld>
             <a:endParaRPr lang="en-NZ"/>
           </a:p>
@@ -3933,7 +3933,7 @@
           <a:p>
             <a:fld id="{82AFC869-5EEF-42A8-8244-0DD91ADCD842}" type="datetimeFigureOut">
               <a:rPr lang="en-NZ" smtClean="0"/>
-              <a:t>10/09/2026</a:t>
+              <a:t>12/09/2026</a:t>
             </a:fld>
             <a:endParaRPr lang="en-NZ"/>
           </a:p>
@@ -4377,7 +4377,7 @@
           <a:p>
             <a:fld id="{82AFC869-5EEF-42A8-8244-0DD91ADCD842}" type="datetimeFigureOut">
               <a:rPr lang="en-NZ" smtClean="0"/>
-              <a:t>10/09/2026</a:t>
+              <a:t>12/09/2026</a:t>
             </a:fld>
             <a:endParaRPr lang="en-NZ"/>
           </a:p>
@@ -4495,7 +4495,7 @@
           <a:p>
             <a:fld id="{82AFC869-5EEF-42A8-8244-0DD91ADCD842}" type="datetimeFigureOut">
               <a:rPr lang="en-NZ" smtClean="0"/>
-              <a:t>10/09/2026</a:t>
+              <a:t>12/09/2026</a:t>
             </a:fld>
             <a:endParaRPr lang="en-NZ"/>
           </a:p>
@@ -4590,7 +4590,7 @@
           <a:p>
             <a:fld id="{82AFC869-5EEF-42A8-8244-0DD91ADCD842}" type="datetimeFigureOut">
               <a:rPr lang="en-NZ" smtClean="0"/>
-              <a:t>10/09/2026</a:t>
+              <a:t>12/09/2026</a:t>
             </a:fld>
             <a:endParaRPr lang="en-NZ"/>
           </a:p>
@@ -4869,7 +4869,7 @@
           <a:p>
             <a:fld id="{82AFC869-5EEF-42A8-8244-0DD91ADCD842}" type="datetimeFigureOut">
               <a:rPr lang="en-NZ" smtClean="0"/>
-              <a:t>10/09/2026</a:t>
+              <a:t>12/09/2026</a:t>
             </a:fld>
             <a:endParaRPr lang="en-NZ"/>
           </a:p>
@@ -5144,7 +5144,7 @@
           <a:p>
             <a:fld id="{82AFC869-5EEF-42A8-8244-0DD91ADCD842}" type="datetimeFigureOut">
               <a:rPr lang="en-NZ" smtClean="0"/>
-              <a:t>10/09/2026</a:t>
+              <a:t>12/09/2026</a:t>
             </a:fld>
             <a:endParaRPr lang="en-NZ"/>
           </a:p>
@@ -5587,7 +5587,7 @@
           <a:p>
             <a:fld id="{82AFC869-5EEF-42A8-8244-0DD91ADCD842}" type="datetimeFigureOut">
               <a:rPr lang="en-NZ" smtClean="0"/>
-              <a:t>10/09/2026</a:t>
+              <a:t>12/09/2026</a:t>
             </a:fld>
             <a:endParaRPr lang="en-NZ"/>
           </a:p>
@@ -6198,13 +6198,8 @@
               <a:rPr lang="en-NZ" dirty="0">
                 <a:latin typeface="Century Gothic" panose="020B0502020202020204" pitchFamily="34" charset="0"/>
               </a:rPr>
-              <a:t>BHB Capstone project</a:t>
-            </a:r>
-          </a:p>
-          <a:p>
-            <a:endParaRPr lang="en-NZ" dirty="0">
-              <a:latin typeface="Century Gothic" panose="020B0502020202020204" pitchFamily="34" charset="0"/>
-            </a:endParaRPr>
+              <a:t>BHB</a:t>
+            </a:r>
           </a:p>
         </p:txBody>
       </p:sp>
@@ -6915,7 +6910,7 @@
               <a:rPr lang="en-NZ" dirty="0">
                 <a:latin typeface="Century Gothic" panose="020B0502020202020204" pitchFamily="34" charset="0"/>
               </a:rPr>
-              <a:t>Foremost Demonstration</a:t>
+              <a:t>Foremost proof of concept</a:t>
             </a:r>
           </a:p>
           <a:p>
@@ -7149,7 +7144,7 @@
           <a:p>
             <a:r>
               <a:rPr lang="en-US" dirty="0"/>
-              <a:t>All forensics tools installed.</a:t>
+              <a:t>All forensics tools installed</a:t>
             </a:r>
           </a:p>
           <a:p>
@@ -7160,8 +7155,14 @@
           </a:p>
           <a:p>
             <a:r>
+              <a:rPr lang="en-US" dirty="0"/>
+              <a:t>Adequate test case files acquired and organized them</a:t>
+            </a:r>
+          </a:p>
+          <a:p>
+            <a:r>
               <a:rPr lang="en-NZ" dirty="0"/>
-              <a:t>Selected AI model: Gemma4:26b</a:t>
+              <a:t>Tested and selected AI model: Gemma4:26b</a:t>
             </a:r>
           </a:p>
           <a:p>
@@ -7422,7 +7423,7 @@
           <p:cNvPr id="2" name="Title 1">
             <a:extLst>
               <a:ext uri="{FF2B5EF4-FFF2-40B4-BE49-F238E27FC236}">
-                <a16:creationId xmlns:a16="http://schemas.microsoft.com/office/drawing/2014/main" id="{1752F503-BA1E-2D45-51A6-84F7A82F23EE}"/>
+                <a16:creationId xmlns:a16="http://schemas.microsoft.com/office/drawing/2014/main" id="{45E0D38A-9B0C-F7EC-7E40-960AD3FE713C}"/>
               </a:ext>
             </a:extLst>
           </p:cNvPr>
@@ -7440,7 +7441,7 @@
           <a:p>
             <a:r>
               <a:rPr lang="en-NZ" dirty="0"/>
-              <a:t>Emerging insights (Matt)</a:t>
+              <a:t>Foremost Proof of Concept</a:t>
             </a:r>
           </a:p>
         </p:txBody>
@@ -7450,7 +7451,7 @@
           <p:cNvPr id="3" name="Content Placeholder 2">
             <a:extLst>
               <a:ext uri="{FF2B5EF4-FFF2-40B4-BE49-F238E27FC236}">
-                <a16:creationId xmlns:a16="http://schemas.microsoft.com/office/drawing/2014/main" id="{F2F109EC-CF5E-94D0-6F6D-FCD1015433D6}"/>
+                <a16:creationId xmlns:a16="http://schemas.microsoft.com/office/drawing/2014/main" id="{A1BF2D46-F7DC-B8C3-2E45-C4E0D2A1E1C9}"/>
               </a:ext>
             </a:extLst>
           </p:cNvPr>
@@ -7466,14 +7467,73 @@
           <a:bodyPr/>
           <a:lstStyle/>
           <a:p>
-            <a:endParaRPr lang="en-NZ"/>
+            <a:r>
+              <a:rPr lang="en-US" dirty="0"/>
+              <a:t>Foremost “carves” files from forensic disk images. Disk images are bit-by-bit copies of a storage medium. File carving is an essential practice in digital forensics.</a:t>
+            </a:r>
+          </a:p>
+          <a:p>
+            <a:r>
+              <a:rPr lang="en-US" dirty="0"/>
+              <a:t>The team developed a Python 3 script that is used to automate the examination of the “audit.txt” file from Foremost to produce a report.</a:t>
+            </a:r>
+          </a:p>
+          <a:p>
+            <a:r>
+              <a:rPr lang="en-US" dirty="0"/>
+              <a:t>The script also serves to record how long the process takes.</a:t>
+            </a:r>
+          </a:p>
+          <a:p>
+            <a:r>
+              <a:rPr lang="en-US" dirty="0"/>
+              <a:t>This effort represents the successful development/integration of AI enhancement to a digital forensics tool.</a:t>
+            </a:r>
+          </a:p>
+          <a:p>
+            <a:endParaRPr lang="en-US" dirty="0"/>
+          </a:p>
+        </p:txBody>
+      </p:sp>
+      <p:sp>
+        <p:nvSpPr>
+          <p:cNvPr id="4" name="TextBox 3">
+            <a:extLst>
+              <a:ext uri="{FF2B5EF4-FFF2-40B4-BE49-F238E27FC236}">
+                <a16:creationId xmlns:a16="http://schemas.microsoft.com/office/drawing/2014/main" id="{5CB2F7E0-7F7D-16AB-7A23-61A9A04E734F}"/>
+              </a:ext>
+            </a:extLst>
+          </p:cNvPr>
+          <p:cNvSpPr txBox="1"/>
+          <p:nvPr/>
+        </p:nvSpPr>
+        <p:spPr>
+          <a:xfrm>
+            <a:off x="0" y="6898821"/>
+            <a:ext cx="6278336" cy="369332"/>
+          </a:xfrm>
+          <a:prstGeom prst="rect">
+            <a:avLst/>
+          </a:prstGeom>
+          <a:noFill/>
+        </p:spPr>
+        <p:txBody>
+          <a:bodyPr wrap="square" rtlCol="0">
+            <a:spAutoFit/>
+          </a:bodyPr>
+          <a:lstStyle/>
+          <a:p>
+            <a:r>
+              <a:rPr lang="en-NZ" i="1" dirty="0"/>
+              <a:t>And now for something completely different...</a:t>
+            </a:r>
           </a:p>
         </p:txBody>
       </p:sp>
     </p:spTree>
     <p:extLst>
       <p:ext uri="{BB962C8B-B14F-4D97-AF65-F5344CB8AC3E}">
-        <p14:creationId xmlns:p14="http://schemas.microsoft.com/office/powerpoint/2010/main" val="3959275895"/>
+        <p14:creationId xmlns:p14="http://schemas.microsoft.com/office/powerpoint/2010/main" val="1251441915"/>
       </p:ext>
     </p:extLst>
   </p:cSld>
@@ -7505,7 +7565,7 @@
           <p:cNvPr id="2" name="Title 1">
             <a:extLst>
               <a:ext uri="{FF2B5EF4-FFF2-40B4-BE49-F238E27FC236}">
-                <a16:creationId xmlns:a16="http://schemas.microsoft.com/office/drawing/2014/main" id="{45E0D38A-9B0C-F7EC-7E40-960AD3FE713C}"/>
+                <a16:creationId xmlns:a16="http://schemas.microsoft.com/office/drawing/2014/main" id="{1752F503-BA1E-2D45-51A6-84F7A82F23EE}"/>
               </a:ext>
             </a:extLst>
           </p:cNvPr>
@@ -7523,7 +7583,7 @@
           <a:p>
             <a:r>
               <a:rPr lang="en-NZ" dirty="0"/>
-              <a:t>Foremost Proof of Concept</a:t>
+              <a:t>Emerging Insights</a:t>
             </a:r>
           </a:p>
         </p:txBody>
@@ -7533,7 +7593,7 @@
           <p:cNvPr id="3" name="Content Placeholder 2">
             <a:extLst>
               <a:ext uri="{FF2B5EF4-FFF2-40B4-BE49-F238E27FC236}">
-                <a16:creationId xmlns:a16="http://schemas.microsoft.com/office/drawing/2014/main" id="{A1BF2D46-F7DC-B8C3-2E45-C4E0D2A1E1C9}"/>
+                <a16:creationId xmlns:a16="http://schemas.microsoft.com/office/drawing/2014/main" id="{F2F109EC-CF5E-94D0-6F6D-FCD1015433D6}"/>
               </a:ext>
             </a:extLst>
           </p:cNvPr>
@@ -7544,57 +7604,50 @@
             <p:ph idx="1"/>
           </p:nvPr>
         </p:nvSpPr>
-        <p:spPr/>
-        <p:txBody>
-          <a:bodyPr/>
-          <a:lstStyle/>
-          <a:p>
-            <a:r>
-              <a:rPr lang="en-NZ" dirty="0"/>
-              <a:t>Now we will demonstrate a proof of concept </a:t>
-            </a:r>
-          </a:p>
-        </p:txBody>
-      </p:sp>
-      <p:sp>
-        <p:nvSpPr>
-          <p:cNvPr id="4" name="TextBox 3">
-            <a:extLst>
-              <a:ext uri="{FF2B5EF4-FFF2-40B4-BE49-F238E27FC236}">
-                <a16:creationId xmlns:a16="http://schemas.microsoft.com/office/drawing/2014/main" id="{5CB2F7E0-7F7D-16AB-7A23-61A9A04E734F}"/>
-              </a:ext>
-            </a:extLst>
-          </p:cNvPr>
-          <p:cNvSpPr txBox="1"/>
-          <p:nvPr/>
-        </p:nvSpPr>
         <p:spPr>
           <a:xfrm>
-            <a:off x="0" y="6898821"/>
-            <a:ext cx="6278336" cy="369332"/>
+            <a:off x="875201" y="1504278"/>
+            <a:ext cx="8946541" cy="4195481"/>
           </a:xfrm>
-          <a:prstGeom prst="rect">
-            <a:avLst/>
-          </a:prstGeom>
-          <a:noFill/>
         </p:spPr>
         <p:txBody>
-          <a:bodyPr wrap="square" rtlCol="0">
-            <a:spAutoFit/>
-          </a:bodyPr>
-          <a:lstStyle/>
-          <a:p>
-            <a:r>
-              <a:rPr lang="en-NZ" i="1" dirty="0"/>
-              <a:t>And now for something completely different...</a:t>
-            </a:r>
+          <a:bodyPr/>
+          <a:lstStyle/>
+          <a:p>
+            <a:r>
+              <a:rPr lang="en-US" dirty="0"/>
+              <a:t>LLM-augmented Foremost reporting takes about 15-35 seconds on a disk image that takes a human examiner 30-57 minutes.</a:t>
+            </a:r>
+          </a:p>
+          <a:p>
+            <a:r>
+              <a:rPr lang="en-US" dirty="0"/>
+              <a:t>Documents that are too long will fail to pass all of their data into an </a:t>
+            </a:r>
+            <a:r>
+              <a:rPr lang="en-US" dirty="0" err="1"/>
+              <a:t>Ollama</a:t>
+            </a:r>
+            <a:r>
+              <a:rPr lang="en-US" dirty="0"/>
+              <a:t> prompt, this represents a significant drawback of locally hosted AI models, their limited context window, this was addressed through simple prompt chunking.</a:t>
+            </a:r>
+          </a:p>
+          <a:p>
+            <a:r>
+              <a:rPr lang="en-US" dirty="0"/>
+              <a:t>Vision models inspecting digital images have trouble reading small text, it will hallucinate and fabricate false information even with strict prompting, LLMs seem to have trouble asserting ignorance.</a:t>
+            </a:r>
+          </a:p>
+          <a:p>
+            <a:endParaRPr lang="en-NZ" dirty="0"/>
           </a:p>
         </p:txBody>
       </p:sp>
     </p:spTree>
     <p:extLst>
       <p:ext uri="{BB962C8B-B14F-4D97-AF65-F5344CB8AC3E}">
-        <p14:creationId xmlns:p14="http://schemas.microsoft.com/office/powerpoint/2010/main" val="1251441915"/>
+        <p14:creationId xmlns:p14="http://schemas.microsoft.com/office/powerpoint/2010/main" val="3959275895"/>
       </p:ext>
     </p:extLst>
   </p:cSld>

</xml_diff>